<commit_message>
docs: fill live URL (https://rassah.vercel.app) in README, report and deck
Co-Authored-By: Claude Opus 5.5 <noreply@anthropic.com>
</commit_message>
<xml_diff>
--- a/docs/report/deck.pptx
+++ b/docs/report/deck.pptx
@@ -726,7 +726,7 @@
           <a:p>
             <a:r>
               <a:rPr lang="en-US" dirty="0"/>
-              <a:t>Speaker M3 (2:55–3:00). Thank the judges; repo and live URL on screen. Replace LIVE_URL_TBD with the Vercel production URL before Thursday.</a:t>
+              <a:t>Speaker M3 (2:55–3:00). Thank the judges; repo and live URL on screen. Replace https://rassah.vercel.app with the Vercel production URL before Thursday.</a:t>
             </a:r>
             <a:endParaRPr lang="en-US" dirty="0"/>
           </a:p>
@@ -2493,6 +2493,10 @@
             <a:prstDash val="solid"/>
           </a:ln>
         </p:spPr>
+        <p:txBody>
+          <a:bodyPr/>
+          <a:p/>
+        </p:txBody>
       </p:sp>
       <p:sp>
         <p:nvSpPr>
@@ -2520,6 +2524,10 @@
             <a:prstDash val="solid"/>
           </a:ln>
         </p:spPr>
+        <p:txBody>
+          <a:bodyPr/>
+          <a:p/>
+        </p:txBody>
       </p:sp>
       <p:sp>
         <p:nvSpPr>
@@ -2547,6 +2555,10 @@
             <a:prstDash val="solid"/>
           </a:ln>
         </p:spPr>
+        <p:txBody>
+          <a:bodyPr/>
+          <a:p/>
+        </p:txBody>
       </p:sp>
       <p:sp>
         <p:nvSpPr>
@@ -2831,6 +2843,10 @@
             <a:prstDash val="solid"/>
           </a:ln>
         </p:spPr>
+        <p:txBody>
+          <a:bodyPr/>
+          <a:p/>
+        </p:txBody>
       </p:sp>
       <p:sp>
         <p:nvSpPr>
@@ -2858,6 +2874,10 @@
             <a:prstDash val="solid"/>
           </a:ln>
         </p:spPr>
+        <p:txBody>
+          <a:bodyPr/>
+          <a:p/>
+        </p:txBody>
       </p:sp>
       <p:sp>
         <p:nvSpPr>
@@ -3029,6 +3049,10 @@
             <a:prstDash val="solid"/>
           </a:ln>
         </p:spPr>
+        <p:txBody>
+          <a:bodyPr/>
+          <a:p/>
+        </p:txBody>
       </p:sp>
       <p:sp>
         <p:nvSpPr>
@@ -3056,6 +3080,10 @@
             <a:prstDash val="solid"/>
           </a:ln>
         </p:spPr>
+        <p:txBody>
+          <a:bodyPr/>
+          <a:p/>
+        </p:txBody>
       </p:sp>
       <p:sp>
         <p:nvSpPr>
@@ -3227,6 +3255,10 @@
             <a:prstDash val="solid"/>
           </a:ln>
         </p:spPr>
+        <p:txBody>
+          <a:bodyPr/>
+          <a:p/>
+        </p:txBody>
       </p:sp>
       <p:sp>
         <p:nvSpPr>
@@ -3254,6 +3286,10 @@
             <a:prstDash val="solid"/>
           </a:ln>
         </p:spPr>
+        <p:txBody>
+          <a:bodyPr/>
+          <a:p/>
+        </p:txBody>
       </p:sp>
       <p:sp>
         <p:nvSpPr>
@@ -3722,7 +3758,7 @@
                   <a:schemeClr val="bg1"/>
                 </a:solidFill>
               </a:rPr>
-              <a:t>LIVE_URL_TBD</a:t>
+              <a:t>https://rassah.vercel.app</a:t>
             </a:r>
             <a:endParaRPr lang="en-US" sz="1800" dirty="0"/>
           </a:p>
@@ -3790,6 +3826,10 @@
             <a:prstDash val="solid"/>
           </a:ln>
         </p:spPr>
+        <p:txBody>
+          <a:bodyPr/>
+          <a:p/>
+        </p:txBody>
       </p:sp>
       <p:sp>
         <p:nvSpPr>
@@ -3817,6 +3857,10 @@
             <a:prstDash val="solid"/>
           </a:ln>
         </p:spPr>
+        <p:txBody>
+          <a:bodyPr/>
+          <a:p/>
+        </p:txBody>
       </p:sp>
       <p:sp>
         <p:nvSpPr>
@@ -3844,6 +3888,10 @@
             <a:prstDash val="solid"/>
           </a:ln>
         </p:spPr>
+        <p:txBody>
+          <a:bodyPr/>
+          <a:p/>
+        </p:txBody>
       </p:sp>
     </p:spTree>
   </p:cSld>
@@ -4066,6 +4114,10 @@
             <a:prstDash val="solid"/>
           </a:ln>
         </p:spPr>
+        <p:txBody>
+          <a:bodyPr/>
+          <a:p/>
+        </p:txBody>
       </p:sp>
       <p:sp>
         <p:nvSpPr>
@@ -4140,6 +4192,10 @@
             <a:tailEnd type="triangle"/>
           </a:ln>
         </p:spPr>
+        <p:txBody>
+          <a:bodyPr/>
+          <a:p/>
+        </p:txBody>
       </p:sp>
       <p:sp>
         <p:nvSpPr>
@@ -4167,6 +4223,10 @@
             <a:prstDash val="solid"/>
           </a:ln>
         </p:spPr>
+        <p:txBody>
+          <a:bodyPr/>
+          <a:p/>
+        </p:txBody>
       </p:sp>
       <p:sp>
         <p:nvSpPr>
@@ -4241,6 +4301,10 @@
             <a:tailEnd type="triangle"/>
           </a:ln>
         </p:spPr>
+        <p:txBody>
+          <a:bodyPr/>
+          <a:p/>
+        </p:txBody>
       </p:sp>
       <p:sp>
         <p:nvSpPr>
@@ -4268,6 +4332,10 @@
             <a:prstDash val="solid"/>
           </a:ln>
         </p:spPr>
+        <p:txBody>
+          <a:bodyPr/>
+          <a:p/>
+        </p:txBody>
       </p:sp>
       <p:sp>
         <p:nvSpPr>
@@ -4328,6 +4396,10 @@
             <a:tailEnd type="triangle"/>
           </a:ln>
         </p:spPr>
+        <p:txBody>
+          <a:bodyPr/>
+          <a:p/>
+        </p:txBody>
       </p:sp>
       <p:sp>
         <p:nvSpPr>
@@ -4355,6 +4427,10 @@
             <a:prstDash val="solid"/>
           </a:ln>
         </p:spPr>
+        <p:txBody>
+          <a:bodyPr/>
+          <a:p/>
+        </p:txBody>
       </p:sp>
       <p:sp>
         <p:nvSpPr>
@@ -4443,6 +4519,10 @@
             <a:tailEnd type="triangle"/>
           </a:ln>
         </p:spPr>
+        <p:txBody>
+          <a:bodyPr/>
+          <a:p/>
+        </p:txBody>
       </p:sp>
       <p:sp>
         <p:nvSpPr>
@@ -4470,6 +4550,10 @@
             <a:prstDash val="solid"/>
           </a:ln>
         </p:spPr>
+        <p:txBody>
+          <a:bodyPr/>
+          <a:p/>
+        </p:txBody>
       </p:sp>
       <p:sp>
         <p:nvSpPr>
@@ -4547,6 +4631,10 @@
             <a:prstDash val="solid"/>
           </a:ln>
         </p:spPr>
+        <p:txBody>
+          <a:bodyPr/>
+          <a:p/>
+        </p:txBody>
       </p:sp>
       <p:sp>
         <p:nvSpPr>
@@ -4610,6 +4698,10 @@
             <a:prstDash val="solid"/>
           </a:ln>
         </p:spPr>
+        <p:txBody>
+          <a:bodyPr/>
+          <a:p/>
+        </p:txBody>
       </p:sp>
       <p:sp>
         <p:nvSpPr>
@@ -4687,6 +4779,10 @@
             <a:prstDash val="solid"/>
           </a:ln>
         </p:spPr>
+        <p:txBody>
+          <a:bodyPr/>
+          <a:p/>
+        </p:txBody>
       </p:sp>
       <p:sp>
         <p:nvSpPr>
@@ -4764,6 +4860,10 @@
             <a:prstDash val="solid"/>
           </a:ln>
         </p:spPr>
+        <p:txBody>
+          <a:bodyPr/>
+          <a:p/>
+        </p:txBody>
       </p:sp>
       <p:sp>
         <p:nvSpPr>
@@ -4841,6 +4941,10 @@
             <a:prstDash val="solid"/>
           </a:ln>
         </p:spPr>
+        <p:txBody>
+          <a:bodyPr/>
+          <a:p/>
+        </p:txBody>
       </p:sp>
       <p:sp>
         <p:nvSpPr>
@@ -4901,6 +5005,10 @@
             <a:tailEnd type="triangle"/>
           </a:ln>
         </p:spPr>
+        <p:txBody>
+          <a:bodyPr/>
+          <a:p/>
+        </p:txBody>
       </p:sp>
       <p:sp>
         <p:nvSpPr>
@@ -4925,6 +5033,10 @@
             <a:tailEnd type="triangle"/>
           </a:ln>
         </p:spPr>
+        <p:txBody>
+          <a:bodyPr/>
+          <a:p/>
+        </p:txBody>
       </p:sp>
       <p:sp>
         <p:nvSpPr>
@@ -4949,6 +5061,10 @@
             <a:tailEnd type="triangle"/>
           </a:ln>
         </p:spPr>
+        <p:txBody>
+          <a:bodyPr/>
+          <a:p/>
+        </p:txBody>
       </p:sp>
       <p:sp>
         <p:nvSpPr>
@@ -4973,6 +5089,10 @@
             <a:tailEnd type="triangle"/>
           </a:ln>
         </p:spPr>
+        <p:txBody>
+          <a:bodyPr/>
+          <a:p/>
+        </p:txBody>
       </p:sp>
       <p:sp>
         <p:nvSpPr>
@@ -4997,6 +5117,10 @@
             <a:tailEnd type="triangle"/>
           </a:ln>
         </p:spPr>
+        <p:txBody>
+          <a:bodyPr/>
+          <a:p/>
+        </p:txBody>
       </p:sp>
       <p:sp>
         <p:nvSpPr>
@@ -5021,6 +5145,10 @@
             <a:tailEnd type="triangle"/>
           </a:ln>
         </p:spPr>
+        <p:txBody>
+          <a:bodyPr/>
+          <a:p/>
+        </p:txBody>
       </p:sp>
       <p:sp>
         <p:nvSpPr>
@@ -5048,6 +5176,10 @@
             <a:prstDash val="solid"/>
           </a:ln>
         </p:spPr>
+        <p:txBody>
+          <a:bodyPr/>
+          <a:p/>
+        </p:txBody>
       </p:sp>
       <p:sp>
         <p:nvSpPr>
@@ -5230,6 +5362,10 @@
             <a:prstDash val="solid"/>
           </a:ln>
         </p:spPr>
+        <p:txBody>
+          <a:bodyPr/>
+          <a:p/>
+        </p:txBody>
       </p:sp>
       <p:sp>
         <p:nvSpPr>
@@ -5354,6 +5490,10 @@
             <a:tailEnd type="triangle"/>
           </a:ln>
         </p:spPr>
+        <p:txBody>
+          <a:bodyPr/>
+          <a:p/>
+        </p:txBody>
       </p:sp>
       <p:sp>
         <p:nvSpPr>
@@ -5381,6 +5521,10 @@
             <a:prstDash val="solid"/>
           </a:ln>
         </p:spPr>
+        <p:txBody>
+          <a:bodyPr/>
+          <a:p/>
+        </p:txBody>
       </p:sp>
       <p:sp>
         <p:nvSpPr>
@@ -5505,6 +5649,10 @@
             <a:tailEnd type="triangle"/>
           </a:ln>
         </p:spPr>
+        <p:txBody>
+          <a:bodyPr/>
+          <a:p/>
+        </p:txBody>
       </p:sp>
       <p:sp>
         <p:nvSpPr>
@@ -5532,6 +5680,10 @@
             <a:prstDash val="solid"/>
           </a:ln>
         </p:spPr>
+        <p:txBody>
+          <a:bodyPr/>
+          <a:p/>
+        </p:txBody>
       </p:sp>
       <p:sp>
         <p:nvSpPr>
@@ -5656,6 +5808,10 @@
             <a:tailEnd type="triangle"/>
           </a:ln>
         </p:spPr>
+        <p:txBody>
+          <a:bodyPr/>
+          <a:p/>
+        </p:txBody>
       </p:sp>
       <p:sp>
         <p:nvSpPr>
@@ -5683,6 +5839,10 @@
             <a:prstDash val="solid"/>
           </a:ln>
         </p:spPr>
+        <p:txBody>
+          <a:bodyPr/>
+          <a:p/>
+        </p:txBody>
       </p:sp>
       <p:sp>
         <p:nvSpPr>
@@ -5810,6 +5970,10 @@
             <a:prstDash val="solid"/>
           </a:ln>
         </p:spPr>
+        <p:txBody>
+          <a:bodyPr/>
+          <a:p/>
+        </p:txBody>
       </p:sp>
       <p:sp>
         <p:nvSpPr>
@@ -5909,6 +6073,10 @@
             <a:prstDash val="solid"/>
           </a:ln>
         </p:spPr>
+        <p:txBody>
+          <a:bodyPr/>
+          <a:p/>
+        </p:txBody>
       </p:sp>
       <p:sp>
         <p:nvSpPr>
@@ -6005,6 +6173,10 @@
             <a:tailEnd type="triangle"/>
           </a:ln>
         </p:spPr>
+        <p:txBody>
+          <a:bodyPr/>
+          <a:p/>
+        </p:txBody>
       </p:sp>
       <p:sp>
         <p:nvSpPr>
@@ -6029,6 +6201,10 @@
             <a:tailEnd type="triangle"/>
           </a:ln>
         </p:spPr>
+        <p:txBody>
+          <a:bodyPr/>
+          <a:p/>
+        </p:txBody>
       </p:sp>
       <p:sp>
         <p:nvSpPr>
@@ -10242,6 +10418,10 @@
             <a:prstDash val="solid"/>
           </a:ln>
         </p:spPr>
+        <p:txBody>
+          <a:bodyPr/>
+          <a:p/>
+        </p:txBody>
       </p:sp>
       <p:sp>
         <p:nvSpPr>
@@ -10269,6 +10449,10 @@
             <a:prstDash val="solid"/>
           </a:ln>
         </p:spPr>
+        <p:txBody>
+          <a:bodyPr/>
+          <a:p/>
+        </p:txBody>
       </p:sp>
       <p:sp>
         <p:nvSpPr>
@@ -10404,6 +10588,10 @@
             <a:prstDash val="solid"/>
           </a:ln>
         </p:spPr>
+        <p:txBody>
+          <a:bodyPr/>
+          <a:p/>
+        </p:txBody>
       </p:sp>
       <p:sp>
         <p:nvSpPr>
@@ -10431,6 +10619,10 @@
             <a:prstDash val="solid"/>
           </a:ln>
         </p:spPr>
+        <p:txBody>
+          <a:bodyPr/>
+          <a:p/>
+        </p:txBody>
       </p:sp>
       <p:sp>
         <p:nvSpPr>
@@ -10566,6 +10758,10 @@
             <a:prstDash val="solid"/>
           </a:ln>
         </p:spPr>
+        <p:txBody>
+          <a:bodyPr/>
+          <a:p/>
+        </p:txBody>
       </p:sp>
       <p:sp>
         <p:nvSpPr>
@@ -10593,6 +10789,10 @@
             <a:prstDash val="solid"/>
           </a:ln>
         </p:spPr>
+        <p:txBody>
+          <a:bodyPr/>
+          <a:p/>
+        </p:txBody>
       </p:sp>
       <p:sp>
         <p:nvSpPr>
@@ -10872,6 +11072,10 @@
             <a:prstDash val="solid"/>
           </a:ln>
         </p:spPr>
+        <p:txBody>
+          <a:bodyPr/>
+          <a:p/>
+        </p:txBody>
       </p:sp>
       <p:sp>
         <p:nvSpPr>
@@ -10899,6 +11103,10 @@
             <a:prstDash val="solid"/>
           </a:ln>
         </p:spPr>
+        <p:txBody>
+          <a:bodyPr/>
+          <a:p/>
+        </p:txBody>
       </p:sp>
       <p:sp>
         <p:nvSpPr>
@@ -11183,6 +11391,10 @@
             <a:tailEnd type="triangle"/>
           </a:ln>
         </p:spPr>
+        <p:txBody>
+          <a:bodyPr/>
+          <a:p/>
+        </p:txBody>
       </p:sp>
       <p:sp>
         <p:nvSpPr>
@@ -11318,6 +11530,10 @@
             <a:prstDash val="solid"/>
           </a:ln>
         </p:spPr>
+        <p:txBody>
+          <a:bodyPr/>
+          <a:p/>
+        </p:txBody>
       </p:sp>
       <p:sp>
         <p:nvSpPr>
@@ -11345,6 +11561,10 @@
             <a:prstDash val="solid"/>
           </a:ln>
         </p:spPr>
+        <p:txBody>
+          <a:bodyPr/>
+          <a:p/>
+        </p:txBody>
       </p:sp>
       <p:sp>
         <p:nvSpPr>
@@ -11513,6 +11733,10 @@
             <a:tailEnd type="triangle"/>
           </a:ln>
         </p:spPr>
+        <p:txBody>
+          <a:bodyPr/>
+          <a:p/>
+        </p:txBody>
       </p:sp>
       <p:sp>
         <p:nvSpPr>
@@ -11540,6 +11764,10 @@
             <a:prstDash val="solid"/>
           </a:ln>
         </p:spPr>
+        <p:txBody>
+          <a:bodyPr/>
+          <a:p/>
+        </p:txBody>
       </p:sp>
       <p:sp>
         <p:nvSpPr>
@@ -11567,6 +11795,10 @@
             <a:prstDash val="solid"/>
           </a:ln>
         </p:spPr>
+        <p:txBody>
+          <a:bodyPr/>
+          <a:p/>
+        </p:txBody>
       </p:sp>
       <p:sp>
         <p:nvSpPr>
@@ -11735,6 +11967,10 @@
             <a:tailEnd type="triangle"/>
           </a:ln>
         </p:spPr>
+        <p:txBody>
+          <a:bodyPr/>
+          <a:p/>
+        </p:txBody>
       </p:sp>
       <p:sp>
         <p:nvSpPr>
@@ -11762,6 +11998,10 @@
             <a:prstDash val="solid"/>
           </a:ln>
         </p:spPr>
+        <p:txBody>
+          <a:bodyPr/>
+          <a:p/>
+        </p:txBody>
       </p:sp>
       <p:sp>
         <p:nvSpPr>
@@ -11789,6 +12029,10 @@
             <a:prstDash val="solid"/>
           </a:ln>
         </p:spPr>
+        <p:txBody>
+          <a:bodyPr/>
+          <a:p/>
+        </p:txBody>
       </p:sp>
       <p:sp>
         <p:nvSpPr>
@@ -12176,6 +12420,10 @@
             <a:prstDash val="solid"/>
           </a:ln>
         </p:spPr>
+        <p:txBody>
+          <a:bodyPr/>
+          <a:p/>
+        </p:txBody>
       </p:sp>
       <p:sp>
         <p:nvSpPr>
@@ -12275,6 +12523,10 @@
             <a:prstDash val="solid"/>
           </a:ln>
         </p:spPr>
+        <p:txBody>
+          <a:bodyPr/>
+          <a:p/>
+        </p:txBody>
       </p:sp>
       <p:sp>
         <p:nvSpPr>
@@ -12374,6 +12626,10 @@
             <a:prstDash val="solid"/>
           </a:ln>
         </p:spPr>
+        <p:txBody>
+          <a:bodyPr/>
+          <a:p/>
+        </p:txBody>
       </p:sp>
       <p:sp>
         <p:nvSpPr>
@@ -12473,6 +12729,10 @@
             <a:prstDash val="solid"/>
           </a:ln>
         </p:spPr>
+        <p:txBody>
+          <a:bodyPr/>
+          <a:p/>
+        </p:txBody>
       </p:sp>
       <p:sp>
         <p:nvSpPr>
@@ -12792,6 +13052,10 @@
             <a:prstDash val="solid"/>
           </a:ln>
         </p:spPr>
+        <p:txBody>
+          <a:bodyPr/>
+          <a:p/>
+        </p:txBody>
       </p:sp>
       <p:sp>
         <p:nvSpPr>
@@ -12819,6 +13083,10 @@
             <a:prstDash val="solid"/>
           </a:ln>
         </p:spPr>
+        <p:txBody>
+          <a:bodyPr/>
+          <a:p/>
+        </p:txBody>
       </p:sp>
       <p:sp>
         <p:nvSpPr>
@@ -12918,6 +13186,10 @@
             <a:prstDash val="solid"/>
           </a:ln>
         </p:spPr>
+        <p:txBody>
+          <a:bodyPr/>
+          <a:p/>
+        </p:txBody>
       </p:sp>
       <p:sp>
         <p:nvSpPr>
@@ -12945,6 +13217,10 @@
             <a:prstDash val="solid"/>
           </a:ln>
         </p:spPr>
+        <p:txBody>
+          <a:bodyPr/>
+          <a:p/>
+        </p:txBody>
       </p:sp>
       <p:sp>
         <p:nvSpPr>
@@ -13044,6 +13320,10 @@
             <a:prstDash val="solid"/>
           </a:ln>
         </p:spPr>
+        <p:txBody>
+          <a:bodyPr/>
+          <a:p/>
+        </p:txBody>
       </p:sp>
       <p:sp>
         <p:nvSpPr>
@@ -13071,6 +13351,10 @@
             <a:prstDash val="solid"/>
           </a:ln>
         </p:spPr>
+        <p:txBody>
+          <a:bodyPr/>
+          <a:p/>
+        </p:txBody>
       </p:sp>
       <p:sp>
         <p:nvSpPr>
@@ -13170,6 +13454,10 @@
             <a:prstDash val="solid"/>
           </a:ln>
         </p:spPr>
+        <p:txBody>
+          <a:bodyPr/>
+          <a:p/>
+        </p:txBody>
       </p:sp>
       <p:sp>
         <p:nvSpPr>
@@ -13197,6 +13485,10 @@
             <a:prstDash val="solid"/>
           </a:ln>
         </p:spPr>
+        <p:txBody>
+          <a:bodyPr/>
+          <a:p/>
+        </p:txBody>
       </p:sp>
       <p:sp>
         <p:nvSpPr>
@@ -13296,6 +13588,10 @@
             <a:prstDash val="solid"/>
           </a:ln>
         </p:spPr>
+        <p:txBody>
+          <a:bodyPr/>
+          <a:p/>
+        </p:txBody>
       </p:sp>
       <p:sp>
         <p:nvSpPr>
@@ -13323,6 +13619,10 @@
             <a:prstDash val="solid"/>
           </a:ln>
         </p:spPr>
+        <p:txBody>
+          <a:bodyPr/>
+          <a:p/>
+        </p:txBody>
       </p:sp>
       <p:sp>
         <p:nvSpPr>
@@ -13566,6 +13866,10 @@
             <a:prstDash val="solid"/>
           </a:ln>
         </p:spPr>
+        <p:txBody>
+          <a:bodyPr/>
+          <a:p/>
+        </p:txBody>
       </p:sp>
       <p:sp>
         <p:nvSpPr>
@@ -13665,6 +13969,10 @@
             <a:prstDash val="solid"/>
           </a:ln>
         </p:spPr>
+        <p:txBody>
+          <a:bodyPr/>
+          <a:p/>
+        </p:txBody>
       </p:sp>
       <p:sp>
         <p:nvSpPr>
@@ -13764,6 +14072,10 @@
             <a:prstDash val="solid"/>
           </a:ln>
         </p:spPr>
+        <p:txBody>
+          <a:bodyPr/>
+          <a:p/>
+        </p:txBody>
       </p:sp>
       <p:sp>
         <p:nvSpPr>
@@ -13863,6 +14175,10 @@
             <a:prstDash val="solid"/>
           </a:ln>
         </p:spPr>
+        <p:txBody>
+          <a:bodyPr/>
+          <a:p/>
+        </p:txBody>
       </p:sp>
       <p:sp>
         <p:nvSpPr>
@@ -13962,6 +14278,10 @@
             <a:prstDash val="solid"/>
           </a:ln>
         </p:spPr>
+        <p:txBody>
+          <a:bodyPr/>
+          <a:p/>
+        </p:txBody>
       </p:sp>
       <p:sp>
         <p:nvSpPr>
@@ -14144,6 +14464,10 @@
             <a:prstDash val="dash"/>
           </a:ln>
         </p:spPr>
+        <p:txBody>
+          <a:bodyPr/>
+          <a:p/>
+        </p:txBody>
       </p:sp>
       <p:sp>
         <p:nvSpPr>
@@ -14221,6 +14545,10 @@
             <a:prstDash val="solid"/>
           </a:ln>
         </p:spPr>
+        <p:txBody>
+          <a:bodyPr/>
+          <a:p/>
+        </p:txBody>
       </p:sp>
       <p:sp>
         <p:nvSpPr>
@@ -14320,6 +14648,10 @@
             <a:prstDash val="solid"/>
           </a:ln>
         </p:spPr>
+        <p:txBody>
+          <a:bodyPr/>
+          <a:p/>
+        </p:txBody>
       </p:sp>
       <p:sp>
         <p:nvSpPr>
@@ -14419,6 +14751,10 @@
             <a:prstDash val="solid"/>
           </a:ln>
         </p:spPr>
+        <p:txBody>
+          <a:bodyPr/>
+          <a:p/>
+        </p:txBody>
       </p:sp>
       <p:sp>
         <p:nvSpPr>
@@ -14518,6 +14854,10 @@
             <a:prstDash val="solid"/>
           </a:ln>
         </p:spPr>
+        <p:txBody>
+          <a:bodyPr/>
+          <a:p/>
+        </p:txBody>
       </p:sp>
       <p:sp>
         <p:nvSpPr>
@@ -14617,6 +14957,10 @@
             <a:prstDash val="solid"/>
           </a:ln>
         </p:spPr>
+        <p:txBody>
+          <a:bodyPr/>
+          <a:p/>
+        </p:txBody>
       </p:sp>
       <p:sp>
         <p:nvSpPr>
@@ -14716,6 +15060,10 @@
             <a:prstDash val="solid"/>
           </a:ln>
         </p:spPr>
+        <p:txBody>
+          <a:bodyPr/>
+          <a:p/>
+        </p:txBody>
       </p:sp>
       <p:sp>
         <p:nvSpPr>
@@ -14815,6 +15163,10 @@
             <a:prstDash val="solid"/>
           </a:ln>
         </p:spPr>
+        <p:txBody>
+          <a:bodyPr/>
+          <a:p/>
+        </p:txBody>
       </p:sp>
       <p:sp>
         <p:nvSpPr>
@@ -14914,6 +15266,10 @@
             <a:prstDash val="solid"/>
           </a:ln>
         </p:spPr>
+        <p:txBody>
+          <a:bodyPr/>
+          <a:p/>
+        </p:txBody>
       </p:sp>
       <p:sp>
         <p:nvSpPr>
@@ -15244,6 +15600,10 @@
             <a:prstDash val="solid"/>
           </a:ln>
         </p:spPr>
+        <p:txBody>
+          <a:bodyPr/>
+          <a:p/>
+        </p:txBody>
       </p:sp>
       <p:sp>
         <p:nvSpPr>

</xml_diff>

<commit_message>
feat: real extraction eval (gemini-3.5-flash-lite, 30/30), docs + deck numbers, fra1 region
- eval/results/extraction-2026-10-21-v1.json: parse/dims/honesty 100%, inferred dim MAPE 14.3% (holdout 18.2%)
- results.md, REPORT §8, qa.md, deck slides 5/7/16 updated; margin stays 15% (decision recorded)
- vercel.json pins functions to fra1 next to Supabase (eu-central-1)

Co-Authored-By: Claude Opus 5.5 <noreply@anthropic.com>
</commit_message>
<xml_diff>
--- a/docs/report/deck.pptx
+++ b/docs/report/deck.pptx
@@ -1518,7 +1518,7 @@
           <a:p>
             <a:r>
               <a:rPr lang="en-US" dirty="0"/>
-              <a:t>Speaker M1 (Q&amp;A backup, or 10 s in the pitch). Source tags page / inferred / unknown. Inferred values get a safety margin; unknown stops the order. Do not quote extraction accuracy: those numbers are pending real Gemini runs.</a:t>
+              <a:t>Speaker M1 (Q&amp;A backup, or 10 s in the pitch). Source tags page / inferred / unknown. Inferred values get a safety margin; unknown stops the order. Extraction (30 synthetic products, 10 holdout, gemini-3.5-flash-lite): 100% parse, dims within 1 cm 100%, honesty on no-info products 100%, estimated-size error 14.3% (holdout 18.2%, only 4 products), so the 15% margin stands.</a:t>
             </a:r>
             <a:endParaRPr lang="en-US" dirty="0"/>
           </a:p>
@@ -1694,7 +1694,7 @@
           <a:p>
             <a:r>
               <a:rPr lang="en-US" dirty="0"/>
-              <a:t>Speaker M2 (1:50–2:20). Validity 100%, zero false claims, recall 15 of 20 on the hardest exact-fill cases, and the naive baseline breaks a rule in 27 of 35 layouts. We do not claim savings. Extraction accuracy numbers are pending; do not quote any.</a:t>
+              <a:t>Speaker M2 (1:50–2:20). Validity 100%, zero false claims, recall 20 of 20 on the hardest exact-fill cases, and the naive baseline breaks a rule in 20 of 28 layouts. We do not claim savings. Extraction: 100% parse, dims within 1 cm 100%, honesty 100%, estimated-dim error 14.3% (holdout 18.2%).</a:t>
             </a:r>
             <a:endParaRPr lang="en-US" dirty="0"/>
           </a:p>
@@ -8966,7 +8966,7 @@
                             <a:schemeClr val="tx1"/>
                           </a:solidFill>
                         </a:rPr>
-                        <a:t>Extraction eval vs ground truth (pending), Zod checks</a:t>
+                        <a:t>Extraction eval vs ground truth (30 products), Zod checks</a:t>
                       </a:r>
                       <a:endParaRPr lang="en-US" sz="1100" dirty="0"/>
                     </a:p>
@@ -12912,7 +12912,7 @@
                   <a:schemeClr val="accent4"/>
                 </a:solidFill>
               </a:rPr>
-              <a:t>The 15% margin will be checked against the measured inferred-size error (extraction eval pending).</a:t>
+              <a:t>The 15% margin will be checked against the measured inferred-size error (extraction eval: holdout 18.2%, all 14.3%).</a:t>
             </a:r>
             <a:endParaRPr lang="en-US" sz="1050" dirty="0"/>
           </a:p>
@@ -13901,7 +13901,7 @@
                   <a:schemeClr val="tx2"/>
                 </a:solidFill>
               </a:rPr>
-              <a:t>35 / 35</a:t>
+              <a:t>40 / 40</a:t>
             </a:r>
             <a:endParaRPr lang="en-US" sz="3400" dirty="0"/>
           </a:p>
@@ -14107,7 +14107,7 @@
                   <a:schemeClr val="accent1"/>
                 </a:solidFill>
               </a:rPr>
-              <a:t>15 / 20</a:t>
+              <a:t>20 / 20</a:t>
             </a:r>
             <a:endParaRPr lang="en-US" sz="3400" dirty="0"/>
           </a:p>
@@ -14143,7 +14143,7 @@
                   <a:schemeClr val="tx1"/>
                 </a:solidFill>
               </a:rPr>
-              <a:t>known-feasible recall on zero-slack exact fills (up from 3 / 20)</a:t>
+              <a:t>known-feasible recall on zero-slack exact fills (up from 3 / 20, then 15 / 20)</a:t>
             </a:r>
             <a:endParaRPr lang="en-US" sz="1300" dirty="0"/>
           </a:p>
@@ -14210,7 +14210,7 @@
                   <a:schemeClr val="accent3"/>
                 </a:solidFill>
               </a:rPr>
-              <a:t>27 / 35</a:t>
+              <a:t>20 / 28</a:t>
             </a:r>
             <a:endParaRPr lang="en-US" sz="3400" dirty="0"/>
           </a:p>
@@ -14313,7 +14313,7 @@
                   <a:schemeClr val="tx1"/>
                 </a:solidFill>
               </a:rPr>
-              <a:t>Extraction eval: pending real Gemini runs. </a:t>
+              <a:t>Extraction (30 products, holdout 10): 100% parse, dims ±1 cm 100%, honesty 100%, estimated-dim error 14%. </a:t>
             </a:r>
             <a:pPr indent="0" marL="0">
               <a:buNone/>
@@ -14324,7 +14324,7 @@
                   <a:schemeClr val="tx1"/>
                 </a:solidFill>
               </a:rPr>
-              <a:t>No cost savings claimed: 0 SAR vs baseline on the 8 fixtures where both are valid. Source: eval/results/packing-2026-10-20-engine-0.1.json</a:t>
+              <a:t>No cost savings claimed: 0 SAR vs baseline on the 8 fixtures where both are valid. Source: eval/results/packing-2026-10-21-engine-0.2.json</a:t>
             </a:r>
             <a:endParaRPr lang="en-US" sz="1250" dirty="0"/>
           </a:p>

</xml_diff>

<commit_message>
docs: screenshots, deck images + PDF, second extraction run, UI/security checks; checklist update
Co-Authored-By: Claude Opus 5.5 <noreply@anthropic.com>
</commit_message>
<xml_diff>
--- a/docs/report/deck.pptx
+++ b/docs/report/deck.pptx
@@ -1518,7 +1518,7 @@
           <a:p>
             <a:r>
               <a:rPr lang="en-US" dirty="0"/>
-              <a:t>Speaker M1 (Q&amp;A backup, or 10 s in the pitch). Source tags page / inferred / unknown. Inferred values get a safety margin; unknown stops the order. Extraction (30 synthetic products, 10 holdout, gemini-3.5-flash-lite): 100% parse, dims within 1 cm 100%, honesty on no-info products 100%, estimated-size error 14.3% (holdout 18.2%, only 4 products), so the 15% margin stands.</a:t>
+              <a:t>Speaker M1 (Q&amp;A backup, or 10 s in the pitch). Source tags page / inferred / unknown. Inferred values get a safety margin; unknown stops the order. Extraction (30 synthetic products, 10 holdout, gemini-3.5-flash-lite): 100% parse, dims within 1 cm 100%, honesty on no-info products 100%, estimated-size error 12.9% in the latest run (14.3% in the first; holdout 16.1% vs 18.2%, only 4 products; LLM run-to-run variation; one fragile false positive in run 2), so the 15% margin stands.</a:t>
             </a:r>
             <a:endParaRPr lang="en-US" dirty="0"/>
           </a:p>
@@ -1694,7 +1694,7 @@
           <a:p>
             <a:r>
               <a:rPr lang="en-US" dirty="0"/>
-              <a:t>Speaker M2 (1:50–2:20). Validity 100%, zero false claims, recall 20 of 20 on the hardest exact-fill cases, and the naive baseline breaks a rule in 20 of 28 layouts. We do not claim savings. Extraction: 100% parse, dims within 1 cm 100%, honesty 100%, estimated-dim error 14.3% (holdout 18.2%).</a:t>
+              <a:t>Speaker M2 (1:50–2:20). Validity 100%, zero false claims, recall 20 of 20 on the hardest exact-fill cases, and the naive baseline breaks a rule in 20 of 28 layouts. We do not claim savings. Extraction: 100% parse, dims within 1 cm 100%, honesty 100%, estimated-dim error 12.9% (first run 14.3%; holdout 16.1% vs 18.2%, run-to-run variation).</a:t>
             </a:r>
             <a:endParaRPr lang="en-US" dirty="0"/>
           </a:p>
@@ -12912,7 +12912,7 @@
                   <a:schemeClr val="accent4"/>
                 </a:solidFill>
               </a:rPr>
-              <a:t>The 15% margin will be checked against the measured inferred-size error (extraction eval: holdout 18.2%, all 14.3%).</a:t>
+              <a:t>The 15% margin will be checked against the measured inferred-size error (extraction eval, two runs: holdout 16.1%, all 12.9%).</a:t>
             </a:r>
             <a:endParaRPr lang="en-US" sz="1050" dirty="0"/>
           </a:p>
@@ -13035,7 +13035,7 @@
         <p:spPr>
           <a:xfrm>
             <a:off x="457200" y="1097280"/>
-            <a:ext cx="8229600" cy="548640"/>
+            <a:ext cx="4572000" cy="548640"/>
           </a:xfrm>
           <a:prstGeom prst="roundRect">
             <a:avLst>
@@ -13065,8 +13065,8 @@
         </p:nvSpPr>
         <p:spPr>
           <a:xfrm>
-            <a:off x="594360" y="1188720"/>
-            <a:ext cx="1325880" cy="365760"/>
+            <a:off x="548640" y="1188720"/>
+            <a:ext cx="1005840" cy="365760"/>
           </a:xfrm>
           <a:prstGeom prst="roundRect">
             <a:avLst>
@@ -13096,8 +13096,8 @@
         </p:nvSpPr>
         <p:spPr>
           <a:xfrm>
-            <a:off x="594360" y="1188720"/>
-            <a:ext cx="1325880" cy="365760"/>
+            <a:off x="548640" y="1188720"/>
+            <a:ext cx="1005840" cy="365760"/>
           </a:xfrm>
           <a:prstGeom prst="rect">
             <a:avLst/>
@@ -13113,7 +13113,7 @@
               <a:buNone/>
             </a:pPr>
             <a:r>
-              <a:rPr lang="en-US" sz="1300" b="1" dirty="0">
+              <a:rPr lang="en-US" sz="1100" b="1" dirty="0">
                 <a:solidFill>
                   <a:schemeClr val="bg1"/>
                 </a:solidFill>
@@ -13132,8 +13132,8 @@
         </p:nvSpPr>
         <p:spPr>
           <a:xfrm>
-            <a:off x="2103120" y="1097280"/>
-            <a:ext cx="6400800" cy="548640"/>
+            <a:off x="1645920" y="1097280"/>
+            <a:ext cx="3337560" cy="548640"/>
           </a:xfrm>
           <a:prstGeom prst="rect">
             <a:avLst/>
@@ -13149,7 +13149,7 @@
               <a:buNone/>
             </a:pPr>
             <a:r>
-              <a:rPr lang="en-US" sz="1400" dirty="0">
+              <a:rPr lang="en-US" sz="1050" dirty="0">
                 <a:solidFill>
                   <a:schemeClr val="tx1"/>
                 </a:solidFill>
@@ -13169,7 +13169,7 @@
         <p:spPr>
           <a:xfrm>
             <a:off x="457200" y="1755648"/>
-            <a:ext cx="8229600" cy="548640"/>
+            <a:ext cx="4572000" cy="548640"/>
           </a:xfrm>
           <a:prstGeom prst="roundRect">
             <a:avLst>
@@ -13199,8 +13199,8 @@
         </p:nvSpPr>
         <p:spPr>
           <a:xfrm>
-            <a:off x="594360" y="1847088"/>
-            <a:ext cx="1325880" cy="365760"/>
+            <a:off x="548640" y="1847088"/>
+            <a:ext cx="1005840" cy="365760"/>
           </a:xfrm>
           <a:prstGeom prst="roundRect">
             <a:avLst>
@@ -13230,8 +13230,8 @@
         </p:nvSpPr>
         <p:spPr>
           <a:xfrm>
-            <a:off x="594360" y="1847088"/>
-            <a:ext cx="1325880" cy="365760"/>
+            <a:off x="548640" y="1847088"/>
+            <a:ext cx="1005840" cy="365760"/>
           </a:xfrm>
           <a:prstGeom prst="rect">
             <a:avLst/>
@@ -13247,7 +13247,7 @@
               <a:buNone/>
             </a:pPr>
             <a:r>
-              <a:rPr lang="en-US" sz="1300" b="1" dirty="0">
+              <a:rPr lang="en-US" sz="1100" b="1" dirty="0">
                 <a:solidFill>
                   <a:schemeClr val="bg1"/>
                 </a:solidFill>
@@ -13266,8 +13266,8 @@
         </p:nvSpPr>
         <p:spPr>
           <a:xfrm>
-            <a:off x="2103120" y="1755648"/>
-            <a:ext cx="6400800" cy="548640"/>
+            <a:off x="1645920" y="1755648"/>
+            <a:ext cx="3337560" cy="548640"/>
           </a:xfrm>
           <a:prstGeom prst="rect">
             <a:avLst/>
@@ -13283,7 +13283,7 @@
               <a:buNone/>
             </a:pPr>
             <a:r>
-              <a:rPr lang="en-US" sz="1400" dirty="0">
+              <a:rPr lang="en-US" sz="1050" dirty="0">
                 <a:solidFill>
                   <a:schemeClr val="tx1"/>
                 </a:solidFill>
@@ -13303,7 +13303,7 @@
         <p:spPr>
           <a:xfrm>
             <a:off x="457200" y="2414016"/>
-            <a:ext cx="8229600" cy="548640"/>
+            <a:ext cx="4572000" cy="548640"/>
           </a:xfrm>
           <a:prstGeom prst="roundRect">
             <a:avLst>
@@ -13333,8 +13333,8 @@
         </p:nvSpPr>
         <p:spPr>
           <a:xfrm>
-            <a:off x="594360" y="2505456"/>
-            <a:ext cx="1325880" cy="365760"/>
+            <a:off x="548640" y="2505456"/>
+            <a:ext cx="1005840" cy="365760"/>
           </a:xfrm>
           <a:prstGeom prst="roundRect">
             <a:avLst>
@@ -13364,8 +13364,8 @@
         </p:nvSpPr>
         <p:spPr>
           <a:xfrm>
-            <a:off x="594360" y="2505456"/>
-            <a:ext cx="1325880" cy="365760"/>
+            <a:off x="548640" y="2505456"/>
+            <a:ext cx="1005840" cy="365760"/>
           </a:xfrm>
           <a:prstGeom prst="rect">
             <a:avLst/>
@@ -13381,7 +13381,7 @@
               <a:buNone/>
             </a:pPr>
             <a:r>
-              <a:rPr lang="en-US" sz="1300" b="1" dirty="0">
+              <a:rPr lang="en-US" sz="1100" b="1" dirty="0">
                 <a:solidFill>
                   <a:schemeClr val="bg1"/>
                 </a:solidFill>
@@ -13400,8 +13400,8 @@
         </p:nvSpPr>
         <p:spPr>
           <a:xfrm>
-            <a:off x="2103120" y="2414016"/>
-            <a:ext cx="6400800" cy="548640"/>
+            <a:off x="1645920" y="2414016"/>
+            <a:ext cx="3337560" cy="548640"/>
           </a:xfrm>
           <a:prstGeom prst="rect">
             <a:avLst/>
@@ -13417,7 +13417,7 @@
               <a:buNone/>
             </a:pPr>
             <a:r>
-              <a:rPr lang="en-US" sz="1400" dirty="0">
+              <a:rPr lang="en-US" sz="1050" dirty="0">
                 <a:solidFill>
                   <a:schemeClr val="tx1"/>
                 </a:solidFill>
@@ -13437,7 +13437,7 @@
         <p:spPr>
           <a:xfrm>
             <a:off x="457200" y="3072384"/>
-            <a:ext cx="8229600" cy="548640"/>
+            <a:ext cx="4572000" cy="548640"/>
           </a:xfrm>
           <a:prstGeom prst="roundRect">
             <a:avLst>
@@ -13467,8 +13467,8 @@
         </p:nvSpPr>
         <p:spPr>
           <a:xfrm>
-            <a:off x="594360" y="3163824"/>
-            <a:ext cx="1325880" cy="365760"/>
+            <a:off x="548640" y="3163824"/>
+            <a:ext cx="1005840" cy="365760"/>
           </a:xfrm>
           <a:prstGeom prst="roundRect">
             <a:avLst>
@@ -13498,8 +13498,8 @@
         </p:nvSpPr>
         <p:spPr>
           <a:xfrm>
-            <a:off x="594360" y="3163824"/>
-            <a:ext cx="1325880" cy="365760"/>
+            <a:off x="548640" y="3163824"/>
+            <a:ext cx="1005840" cy="365760"/>
           </a:xfrm>
           <a:prstGeom prst="rect">
             <a:avLst/>
@@ -13515,7 +13515,7 @@
               <a:buNone/>
             </a:pPr>
             <a:r>
-              <a:rPr lang="en-US" sz="1300" b="1" dirty="0">
+              <a:rPr lang="en-US" sz="1100" b="1" dirty="0">
                 <a:solidFill>
                   <a:schemeClr val="bg1"/>
                 </a:solidFill>
@@ -13534,8 +13534,8 @@
         </p:nvSpPr>
         <p:spPr>
           <a:xfrm>
-            <a:off x="2103120" y="3072384"/>
-            <a:ext cx="6400800" cy="548640"/>
+            <a:off x="1645920" y="3072384"/>
+            <a:ext cx="3337560" cy="548640"/>
           </a:xfrm>
           <a:prstGeom prst="rect">
             <a:avLst/>
@@ -13551,7 +13551,7 @@
               <a:buNone/>
             </a:pPr>
             <a:r>
-              <a:rPr lang="en-US" sz="1400" dirty="0">
+              <a:rPr lang="en-US" sz="1050" dirty="0">
                 <a:solidFill>
                   <a:schemeClr val="tx1"/>
                 </a:solidFill>
@@ -13571,7 +13571,7 @@
         <p:spPr>
           <a:xfrm>
             <a:off x="457200" y="3730752"/>
-            <a:ext cx="8229600" cy="548640"/>
+            <a:ext cx="4572000" cy="548640"/>
           </a:xfrm>
           <a:prstGeom prst="roundRect">
             <a:avLst>
@@ -13601,8 +13601,8 @@
         </p:nvSpPr>
         <p:spPr>
           <a:xfrm>
-            <a:off x="594360" y="3822192"/>
-            <a:ext cx="1325880" cy="365760"/>
+            <a:off x="548640" y="3822192"/>
+            <a:ext cx="1005840" cy="365760"/>
           </a:xfrm>
           <a:prstGeom prst="roundRect">
             <a:avLst>
@@ -13632,8 +13632,8 @@
         </p:nvSpPr>
         <p:spPr>
           <a:xfrm>
-            <a:off x="594360" y="3822192"/>
-            <a:ext cx="1325880" cy="365760"/>
+            <a:off x="548640" y="3822192"/>
+            <a:ext cx="1005840" cy="365760"/>
           </a:xfrm>
           <a:prstGeom prst="rect">
             <a:avLst/>
@@ -13649,7 +13649,7 @@
               <a:buNone/>
             </a:pPr>
             <a:r>
-              <a:rPr lang="en-US" sz="1300" b="1" dirty="0">
+              <a:rPr lang="en-US" sz="1100" b="1" dirty="0">
                 <a:solidFill>
                   <a:schemeClr val="bg1"/>
                 </a:solidFill>
@@ -13668,8 +13668,8 @@
         </p:nvSpPr>
         <p:spPr>
           <a:xfrm>
-            <a:off x="2103120" y="3730752"/>
-            <a:ext cx="6400800" cy="548640"/>
+            <a:off x="1645920" y="3730752"/>
+            <a:ext cx="3337560" cy="548640"/>
           </a:xfrm>
           <a:prstGeom prst="rect">
             <a:avLst/>
@@ -13685,7 +13685,7 @@
               <a:buNone/>
             </a:pPr>
             <a:r>
-              <a:rPr lang="en-US" sz="1400" dirty="0">
+              <a:rPr lang="en-US" sz="1050" dirty="0">
                 <a:solidFill>
                   <a:schemeClr val="tx1"/>
                 </a:solidFill>
@@ -13726,7 +13726,7 @@
                   <a:schemeClr val="accent4"/>
                 </a:solidFill>
               </a:rPr>
-              <a:t>Backup if the live demo fails: recorded video docs/report/demo.mp4 and screenshots in docs/report/screens/ (to be captured before Thursday).</a:t>
+              <a:t>Backup if the live demo fails: recorded video docs/report/demo.mp4 and backup screenshots in docs/report/screens/.</a:t>
             </a:r>
             <a:endParaRPr lang="en-US" sz="1050" dirty="0"/>
           </a:p>
@@ -13777,6 +13777,35 @@
           </a:p>
         </p:txBody>
       </p:sp>
+      <p:pic>
+        <p:nvPicPr>
+          <p:cNvPr id="26" name="img-order-1002" descr="02-order-1002-result.png"/>
+          <p:cNvPicPr>
+            <a:picLocks noChangeAspect="1"/>
+          </p:cNvPicPr>
+          <p:nvPr/>
+        </p:nvPicPr>
+        <p:blipFill>
+          <a:blip r:embed="rId3"/>
+          <a:stretch>
+            <a:fillRect/>
+          </a:stretch>
+        </p:blipFill>
+        <p:spPr>
+          <a:xfrm>
+            <a:off x="5212080" y="1602486"/>
+            <a:ext cx="3474720" cy="2171700"/>
+          </a:xfrm>
+          <a:prstGeom prst="rect">
+            <a:avLst/>
+          </a:prstGeom>
+          <a:ln w="9525">
+            <a:solidFill>
+              <a:srgbClr val="C8C8C8"/>
+            </a:solidFill>
+          </a:ln>
+        </p:spPr>
+      </p:pic>
     </p:spTree>
   </p:cSld>
   <p:clrMapOvr>
@@ -14313,7 +14342,7 @@
                   <a:schemeClr val="tx1"/>
                 </a:solidFill>
               </a:rPr>
-              <a:t>Extraction (30 products, holdout 10): 100% parse, dims ±1 cm 100%, honesty 100%, estimated-dim error 14%. </a:t>
+              <a:t>Extraction (30 products, holdout 10): 100% parse, dims ±1 cm 100%, honesty 100%, estimated-dim error 13%. </a:t>
             </a:r>
             <a:pPr indent="0" marL="0">
               <a:buNone/>
@@ -14440,87 +14469,6 @@
       </p:sp>
       <p:sp>
         <p:nvSpPr>
-          <p:cNvPr id="3" name="dashboard-placeholder"/>
-          <p:cNvSpPr/>
-          <p:nvPr/>
-        </p:nvSpPr>
-        <p:spPr>
-          <a:xfrm>
-            <a:off x="457200" y="1097280"/>
-            <a:ext cx="3931920" cy="2514600"/>
-          </a:xfrm>
-          <a:prstGeom prst="roundRect">
-            <a:avLst>
-              <a:gd name="adj" fmla="val 2909"/>
-            </a:avLst>
-          </a:prstGeom>
-          <a:solidFill>
-            <a:schemeClr val="bg2"/>
-          </a:solidFill>
-          <a:ln w="12700">
-            <a:solidFill>
-              <a:schemeClr val="accent4"/>
-            </a:solidFill>
-            <a:prstDash val="dash"/>
-          </a:ln>
-        </p:spPr>
-        <p:txBody>
-          <a:bodyPr/>
-          <a:p/>
-        </p:txBody>
-      </p:sp>
-      <p:sp>
-        <p:nvSpPr>
-          <p:cNvPr id="4" name="txt-97"/>
-          <p:cNvSpPr txBox="1"/>
-          <p:nvPr/>
-        </p:nvSpPr>
-        <p:spPr>
-          <a:xfrm>
-            <a:off x="640080" y="1097280"/>
-            <a:ext cx="3566160" cy="2514600"/>
-          </a:xfrm>
-          <a:prstGeom prst="rect">
-            <a:avLst/>
-          </a:prstGeom>
-          <a:noFill/>
-          <a:ln/>
-        </p:spPr>
-        <p:txBody>
-          <a:bodyPr wrap="square" lIns="0" tIns="0" rIns="0" bIns="0" rtlCol="0" anchor="ctr"/>
-          <a:lstStyle/>
-          <a:p>
-            <a:pPr algn="ctr" indent="0" marL="0">
-              <a:buNone/>
-            </a:pPr>
-            <a:r>
-              <a:rPr lang="en-US" sz="1300" dirty="0">
-                <a:solidFill>
-                  <a:schemeClr val="accent4"/>
-                </a:solidFill>
-              </a:rPr>
-              <a:t>Dashboard screenshot</a:t>
-            </a:r>
-            <a:endParaRPr lang="en-US" sz="1300" dirty="0"/>
-          </a:p>
-          <a:p>
-            <a:pPr algn="ctr" indent="0" marL="0">
-              <a:buNone/>
-            </a:pPr>
-            <a:r>
-              <a:rPr lang="en-US" sz="1300" dirty="0">
-                <a:solidFill>
-                  <a:schemeClr val="accent4"/>
-                </a:solidFill>
-              </a:rPr>
-              <a:t>(capture from /monitoring on the deployed app)</a:t>
-            </a:r>
-            <a:endParaRPr lang="en-US" sz="1300" dirty="0"/>
-          </a:p>
-        </p:txBody>
-      </p:sp>
-      <p:sp>
-        <p:nvSpPr>
           <p:cNvPr id="5" name="mkey-98"/>
           <p:cNvSpPr/>
           <p:nvPr/>
@@ -15363,6 +15311,35 @@
           </a:p>
         </p:txBody>
       </p:sp>
+      <p:pic>
+        <p:nvPicPr>
+          <p:cNvPr id="28" name="img-monitoring" descr="04-monitoring.png"/>
+          <p:cNvPicPr>
+            <a:picLocks noChangeAspect="1"/>
+          </p:cNvPicPr>
+          <p:nvPr/>
+        </p:nvPicPr>
+        <p:blipFill>
+          <a:blip r:embed="rId3"/>
+          <a:stretch>
+            <a:fillRect/>
+          </a:stretch>
+        </p:blipFill>
+        <p:spPr>
+          <a:xfrm>
+            <a:off x="457200" y="1125855"/>
+            <a:ext cx="3931920" cy="2457450"/>
+          </a:xfrm>
+          <a:prstGeom prst="rect">
+            <a:avLst/>
+          </a:prstGeom>
+          <a:ln w="9525">
+            <a:solidFill>
+              <a:srgbClr val="C8C8C8"/>
+            </a:solidFill>
+          </a:ln>
+        </p:spPr>
+      </p:pic>
     </p:spTree>
   </p:cSld>
   <p:clrMapOvr>

</xml_diff>

<commit_message>
docs: numbers sweep (deck, report, qa), results final, rehearsal/diagram-check/submission aids, runtime check evidence, REPORT.pdf re-export
Co-Authored-By: Claude Opus 5.5 <noreply@anthropic.com>
</commit_message>
<xml_diff>
--- a/docs/report/deck.pptx
+++ b/docs/report/deck.pptx
@@ -726,7 +726,7 @@
           <a:p>
             <a:r>
               <a:rPr lang="en-US" dirty="0"/>
-              <a:t>Speaker M3 (2:55–3:00). Thank the judges; repo and live URL on screen. Replace https://rassah.vercel.app with the Vercel production URL before Thursday.</a:t>
+              <a:t>Speaker M3 (2:55–3:00). Thank the judges; repo and live URL on screen. Live URL is final: https://rassah.vercel.app.</a:t>
             </a:r>
             <a:endParaRPr lang="en-US" dirty="0"/>
           </a:p>
@@ -9212,7 +9212,7 @@
                             <a:schemeClr val="tx1"/>
                           </a:solidFill>
                         </a:rPr>
-                        <a:t>107 tests, CI, evals, end-to-end run</a:t>
+                        <a:t>152 tests, CI, evals, end-to-end run</a:t>
                       </a:r>
                       <a:endParaRPr lang="en-US" sz="1100" dirty="0"/>
                     </a:p>
@@ -15527,7 +15527,7 @@
                   <a:schemeClr val="tx1"/>
                 </a:solidFill>
               </a:rPr>
-              <a:t>Heuristic search: not globally optimal (5 / 20 exact fills missed)</a:t>
+              <a:t>Heuristic search: not globally optimal (finds 20 / 20 exact fills, but time-bounded)</a:t>
             </a:r>
             <a:endParaRPr lang="en-US" sz="1300" dirty="0"/>
           </a:p>

</xml_diff>

<commit_message>
docs: as-built workflow (push to main + local CI gate) replaces stale PR/preview text; landing page noted; REPORT.pdf re-export
Co-Authored-By: Claude Opus 5.5 <noreply@anthropic.com>
</commit_message>
<xml_diff>
--- a/docs/report/deck.pptx
+++ b/docs/report/deck.pptx
@@ -901,10 +901,8 @@
           <a:lstStyle/>
           <a:p>
             <a:r>
-              <a:rPr lang="en-US" dirty="0"/>
-              <a:t>No change reaches main without CI and a teammate's review on a live preview. Production problems come back through the dashboard as issues. Full diagram: docs/report/diagram-dev-flow.png.</a:t>
-            </a:r>
-            <a:endParaRPr lang="en-US" dirty="0"/>
+              <a:t>As built (docs/decisions.md, 2026-10-21): agents work in worktrees, work is merged locally and must pass the local CI gate (agent-ship ci: secret scan, floor guard, lint, typecheck, tests, build, packing eval) before being pushed straight to main. GitHub Actions CI re-runs and Vercel deploys production from main. There was no per-PR review and no branch protection. Production problems come back through the dashboard as issues. The diagram image docs/report/diagram-dev-flow.png shows the original plan.</a:t>
+            </a:r>
           </a:p>
         </p:txBody>
       </p:sp>
@@ -4149,7 +4147,7 @@
                   <a:schemeClr val="tx1"/>
                 </a:solidFill>
               </a:rPr>
-              <a:t>Branch</a:t>
+              <a:t>Agent worktrees</a:t>
             </a:r>
             <a:endParaRPr lang="en-US" sz="1200" dirty="0"/>
           </a:p>
@@ -4163,7 +4161,7 @@
                   <a:schemeClr val="tx1"/>
                 </a:solidFill>
               </a:rPr>
-              <a:t>feat/… fix/…</a:t>
+              <a:t/>
             </a:r>
             <a:endParaRPr lang="en-US" sz="1200" dirty="0"/>
           </a:p>
@@ -4258,7 +4256,7 @@
                   <a:schemeClr val="tx1"/>
                 </a:solidFill>
               </a:rPr>
-              <a:t>Local checks</a:t>
+              <a:t>Local merge +</a:t>
             </a:r>
             <a:endParaRPr lang="en-US" sz="1200" dirty="0"/>
           </a:p>
@@ -4272,7 +4270,7 @@
                   <a:schemeClr val="tx1"/>
                 </a:solidFill>
               </a:rPr>
-              <a:t>npm run check</a:t>
+              <a:t>local CI gate</a:t>
             </a:r>
             <a:endParaRPr lang="en-US" sz="1200" dirty="0"/>
           </a:p>
@@ -4367,7 +4365,7 @@
                   <a:schemeClr val="tx1"/>
                 </a:solidFill>
               </a:rPr>
-              <a:t>Pull request</a:t>
+              <a:t>Push to main</a:t>
             </a:r>
             <a:endParaRPr lang="en-US" sz="1200" dirty="0"/>
           </a:p>
@@ -4490,7 +4488,7 @@
                   <a:schemeClr val="tx1"/>
                 </a:solidFill>
               </a:rPr>
-              <a:t>+ Vercel preview</a:t>
+              <a:t/>
             </a:r>
             <a:endParaRPr lang="en-US" sz="1200" dirty="0"/>
           </a:p>
@@ -4585,7 +4583,7 @@
                   <a:schemeClr val="tx1"/>
                 </a:solidFill>
               </a:rPr>
-              <a:t>Teammate review</a:t>
+              <a:t>Vercel build</a:t>
             </a:r>
             <a:endParaRPr lang="en-US" sz="1200" dirty="0"/>
           </a:p>
@@ -4599,7 +4597,7 @@
                   <a:schemeClr val="tx1"/>
                 </a:solidFill>
               </a:rPr>
-              <a:t>on preview URL</a:t>
+              <a:t>on main</a:t>
             </a:r>
             <a:endParaRPr lang="en-US" sz="1200" dirty="0"/>
           </a:p>
@@ -4666,7 +4664,7 @@
                   <a:schemeClr val="bg1"/>
                 </a:solidFill>
               </a:rPr>
-              <a:t>Merge to main</a:t>
+              <a:t>Main updated</a:t>
             </a:r>
             <a:endParaRPr lang="en-US" sz="1200" dirty="0"/>
           </a:p>
@@ -4976,7 +4974,7 @@
                   <a:schemeClr val="tx1"/>
                 </a:solidFill>
               </a:rPr>
-              <a:t>Issue → new branch</a:t>
+              <a:t>Issue → new worktree</a:t>
             </a:r>
             <a:endParaRPr lang="en-US" sz="1200" dirty="0"/>
           </a:p>
@@ -5222,7 +5220,7 @@
                   <a:schemeClr val="tx1"/>
                 </a:solidFill>
               </a:rPr>
-              <a:t>eval scripts (eval-extraction, eval-packing) → eval_runs in Supabase → evaluation page + report numbers, compared before merging.</a:t>
+              <a:t>eval scripts (eval-extraction, eval-packing) → eval_runs in Supabase → evaluation page + report numbers, compared before pushing.</a:t>
             </a:r>
             <a:endParaRPr lang="en-US" sz="1250" dirty="0"/>
           </a:p>
@@ -9828,7 +9826,7 @@
                             <a:schemeClr val="tx1"/>
                           </a:solidFill>
                         </a:rPr>
-                        <a:t>Hosting, previews, CI</a:t>
+                        <a:t>Hosting, production deploy, CI</a:t>
                       </a:r>
                       <a:endParaRPr lang="en-US" sz="1100" dirty="0"/>
                     </a:p>
@@ -9950,7 +9948,7 @@
                             <a:schemeClr val="tx1"/>
                           </a:solidFill>
                         </a:rPr>
-                        <a:t>CI on every PR</a:t>
+                        <a:t>CI on every push to main</a:t>
                       </a:r>
                       <a:endParaRPr lang="en-US" sz="1100" dirty="0"/>
                     </a:p>

</xml_diff>

<commit_message>
docs: drop merchant-outreach text; bench: head-to-head harness vs Paccurate/3DBinPacking
- Remove the merchant discovery plan and every "we will contact merchants" line
  from the plan, report, deck, Q&A and team docs (no outreach is planned).
- npm run bench: the same orders packed by Rassah, a naive packer and (with
  keys) Paccurate and 3DBinPacking, judged by one validator and one cost
  model. Protocol in docs/benchmark.md, first results in eval/results.
- Checklist: P6.38 (store integration), P9.37-P9.39 (benchmark).

Co-Authored-By: Claude Opus 5.5 <noreply@anthropic.com>
</commit_message>
<xml_diff>
--- a/docs/report/deck.pptx
+++ b/docs/report/deck.pptx
@@ -1252,7 +1252,7 @@
           <a:p>
             <a:r>
               <a:rPr lang="en-US" dirty="0"/>
-              <a:t>Speaker M1 (0:10–0:30). Three problems: volumetric weight, breakage, and missing product data. Say honestly that problem size is a hypothesis.</a:t>
+              <a:t>Speaker M1 (0:10–0:30). Three problems: volumetric weight, breakage, and missing product data.</a:t>
             </a:r>
             <a:endParaRPr lang="en-US" dirty="0"/>
           </a:p>
@@ -10897,42 +10897,6 @@
               <a:t>Cartonization tools assume clean dimensions in a warehouse system. Small Saudi merchants only have free-text product pages in Arabic and English.</a:t>
             </a:r>
             <a:endParaRPr lang="en-US" sz="1300" dirty="0"/>
-          </a:p>
-        </p:txBody>
-      </p:sp>
-      <p:sp>
-        <p:nvSpPr>
-          <p:cNvPr id="18" name="txt-21"/>
-          <p:cNvSpPr txBox="1"/>
-          <p:nvPr/>
-        </p:nvSpPr>
-        <p:spPr>
-          <a:xfrm>
-            <a:off x="457200" y="4224528"/>
-            <a:ext cx="8229600" cy="274320"/>
-          </a:xfrm>
-          <a:prstGeom prst="rect">
-            <a:avLst/>
-          </a:prstGeom>
-          <a:noFill/>
-          <a:ln/>
-        </p:spPr>
-        <p:txBody>
-          <a:bodyPr wrap="square" lIns="0" tIns="0" rIns="0" bIns="0" rtlCol="0" anchor="t"/>
-          <a:lstStyle/>
-          <a:p>
-            <a:pPr indent="0" marL="0">
-              <a:buNone/>
-            </a:pPr>
-            <a:r>
-              <a:rPr lang="en-US" sz="1100" i="1" dirty="0">
-                <a:solidFill>
-                  <a:schemeClr val="accent4"/>
-                </a:solidFill>
-              </a:rPr>
-              <a:t>Problem size is a hypothesis we have not measured. Merchant outreach: docs/discovery.md.</a:t>
-            </a:r>
-            <a:endParaRPr lang="en-US" sz="1100" dirty="0"/>
           </a:p>
         </p:txBody>
       </p:sp>

</xml_diff>